<commit_message>
docs: add timeline deliverables summary
</commit_message>
<xml_diff>
--- a/docs/kickoff/2026-07-15-kickoff-system-preview.pptx
+++ b/docs/kickoff/2026-07-15-kickoff-system-preview.pptx
@@ -6069,7 +6069,7 @@
               <a:buNone/>
             </a:pPr>
             <a:r>
-              <a:rPr lang="en-US" sz="900" dirty="0">
+              <a:rPr lang="th-TH" sz="900">
                 <a:solidFill>
                   <a:srgbClr val="6B7F90"/>
                 </a:solidFill>
@@ -6077,9 +6077,172 @@
                 <a:ea typeface="Tahoma" pitchFamily="34" charset="-122"/>
                 <a:cs typeface="Tahoma" pitchFamily="34" charset="-120"/>
               </a:rPr>
-              <a:t>15 กรกฎาคม 2569  •  5/6</a:t>
+              <a:t>15 กรกฎาคม 2569  •  5/5</a:t>
             </a:r>
             <a:endParaRPr lang="en-US" sz="900" dirty="0"/>
+          </a:p>
+        </p:txBody>
+      </p:sp>
+      <p:sp>
+        <p:nvSpPr>
+          <p:cNvPr id="23" name="DeliverablesSummaryBackground">
+            <a:extLst>
+              <a:ext uri="{FF2B5EF4-FFF2-40B4-BE49-F238E27FC236}">
+                <a16:creationId xmlns:a16="http://schemas.microsoft.com/office/drawing/2014/main" id="{45378C79-82D2-5337-CC36-49FD3EBF1D05}"/>
+              </a:ext>
+            </a:extLst>
+          </p:cNvPr>
+          <p:cNvSpPr/>
+          <p:nvPr/>
+        </p:nvSpPr>
+        <p:spPr>
+          <a:xfrm>
+            <a:off x="508000" y="4572000"/>
+            <a:ext cx="11176000" cy="990600"/>
+          </a:xfrm>
+          <a:prstGeom prst="roundRect">
+            <a:avLst/>
+          </a:prstGeom>
+          <a:solidFill>
+            <a:srgbClr val="E6F3F3"/>
+          </a:solidFill>
+          <a:ln w="12700">
+            <a:solidFill>
+              <a:srgbClr val="B9DADA"/>
+            </a:solidFill>
+          </a:ln>
+        </p:spPr>
+        <p:style>
+          <a:lnRef idx="2">
+            <a:schemeClr val="accent1">
+              <a:shade val="15000"/>
+            </a:schemeClr>
+          </a:lnRef>
+          <a:fillRef idx="1">
+            <a:schemeClr val="accent1"/>
+          </a:fillRef>
+          <a:effectRef idx="0">
+            <a:schemeClr val="accent1"/>
+          </a:effectRef>
+          <a:fontRef idx="minor">
+            <a:schemeClr val="lt1"/>
+          </a:fontRef>
+        </p:style>
+        <p:txBody>
+          <a:bodyPr rtlCol="0" anchor="ctr"/>
+          <a:lstStyle/>
+          <a:p>
+            <a:pPr algn="ctr"/>
+            <a:endParaRPr lang="th-TH"/>
+          </a:p>
+        </p:txBody>
+      </p:sp>
+      <p:sp>
+        <p:nvSpPr>
+          <p:cNvPr id="24" name="DeliverablesSummaryTitle">
+            <a:extLst>
+              <a:ext uri="{FF2B5EF4-FFF2-40B4-BE49-F238E27FC236}">
+                <a16:creationId xmlns:a16="http://schemas.microsoft.com/office/drawing/2014/main" id="{7FB11A5B-6033-2599-3372-367EDE8F997E}"/>
+              </a:ext>
+            </a:extLst>
+          </p:cNvPr>
+          <p:cNvSpPr txBox="1"/>
+          <p:nvPr/>
+        </p:nvSpPr>
+        <p:spPr>
+          <a:xfrm>
+            <a:off x="787400" y="4889500"/>
+            <a:ext cx="1651000" cy="330200"/>
+          </a:xfrm>
+          <a:prstGeom prst="rect">
+            <a:avLst/>
+          </a:prstGeom>
+          <a:noFill/>
+        </p:spPr>
+        <p:txBody>
+          <a:bodyPr vert="horz" lIns="0" tIns="0" rIns="0" bIns="0" rtlCol="0" anchor="ctr">
+            <a:noAutofit/>
+          </a:bodyPr>
+          <a:lstStyle/>
+          <a:p>
+            <a:r>
+              <a:rPr lang="th-TH" sz="1600" b="1">
+                <a:solidFill>
+                  <a:srgbClr val="2A7F80"/>
+                </a:solidFill>
+                <a:latin typeface="Tahoma" panose="020B0604030504040204" pitchFamily="34" charset="0"/>
+              </a:rPr>
+              <a:t>สิ่งส่งมอบหลัก</a:t>
+            </a:r>
+          </a:p>
+        </p:txBody>
+      </p:sp>
+      <p:sp>
+        <p:nvSpPr>
+          <p:cNvPr id="25" name="DeliverablesSummaryItems">
+            <a:extLst>
+              <a:ext uri="{FF2B5EF4-FFF2-40B4-BE49-F238E27FC236}">
+                <a16:creationId xmlns:a16="http://schemas.microsoft.com/office/drawing/2014/main" id="{7062F291-A7A9-7766-5836-9C536B4906B4}"/>
+              </a:ext>
+            </a:extLst>
+          </p:cNvPr>
+          <p:cNvSpPr txBox="1"/>
+          <p:nvPr/>
+        </p:nvSpPr>
+        <p:spPr>
+          <a:xfrm>
+            <a:off x="2476500" y="4699000"/>
+            <a:ext cx="8890000" cy="685800"/>
+          </a:xfrm>
+          <a:prstGeom prst="rect">
+            <a:avLst/>
+          </a:prstGeom>
+          <a:noFill/>
+        </p:spPr>
+        <p:txBody>
+          <a:bodyPr vert="horz" wrap="square" lIns="0" tIns="0" rIns="0" bIns="0" rtlCol="0" anchor="ctr">
+            <a:noAutofit/>
+          </a:bodyPr>
+          <a:lstStyle/>
+          <a:p>
+            <a:r>
+              <a:rPr lang="en-US" sz="1500">
+                <a:solidFill>
+                  <a:srgbClr val="486174"/>
+                </a:solidFill>
+                <a:latin typeface="Tahoma" panose="020B0604030504040204" pitchFamily="34" charset="0"/>
+              </a:rPr>
+              <a:t>Source Code </a:t>
+            </a:r>
+            <a:r>
+              <a:rPr lang="th-TH" sz="1500">
+                <a:solidFill>
+                  <a:srgbClr val="486174"/>
+                </a:solidFill>
+                <a:latin typeface="Tahoma" panose="020B0604030504040204" pitchFamily="34" charset="0"/>
+              </a:rPr>
+              <a:t>และฐานข้อมูล • คู่มือผู้ใช้งาน • ผลการทดสอบ </a:t>
+            </a:r>
+            <a:r>
+              <a:rPr lang="en-US" sz="1500">
+                <a:solidFill>
+                  <a:srgbClr val="486174"/>
+                </a:solidFill>
+                <a:latin typeface="Tahoma" panose="020B0604030504040204" pitchFamily="34" charset="0"/>
+              </a:rPr>
+              <a:t>UAT</a:t>
+            </a:r>
+          </a:p>
+          <a:p>
+            <a:r>
+              <a:rPr lang="th-TH" sz="1500">
+                <a:solidFill>
+                  <a:srgbClr val="486174"/>
+                </a:solidFill>
+                <a:latin typeface="Tahoma" panose="020B0604030504040204" pitchFamily="34" charset="0"/>
+              </a:rPr>
+              <a:t>การติดตั้ง อบรม และดูแลหลังขึ้นระบบ</a:t>
+            </a:r>
           </a:p>
         </p:txBody>
       </p:sp>

</xml_diff>

<commit_message>
docs: update training and UAT materials
</commit_message>
<xml_diff>
--- a/docs/kickoff/2026-07-15-kickoff-system-preview.pptx
+++ b/docs/kickoff/2026-07-15-kickoff-system-preview.pptx
@@ -1683,6 +1683,200 @@
           </a:p>
         </p:txBody>
       </p:sp>
+      <p:pic>
+        <p:nvPicPr>
+          <p:cNvPr id="23" name="รูปภาพ 22" descr="Intelligent Software Solutions&#10;&#10;เนื้อหาที่สร้างโดย AI อาจไม่ถูกต้อง">
+            <a:extLst>
+              <a:ext uri="{FF2B5EF4-FFF2-40B4-BE49-F238E27FC236}">
+                <a16:creationId xmlns:a16="http://schemas.microsoft.com/office/drawing/2014/main" id="{1B1DDEC3-E25B-3C96-EF84-835879C095C1}"/>
+              </a:ext>
+            </a:extLst>
+          </p:cNvPr>
+          <p:cNvPicPr>
+            <a:picLocks noChangeAspect="1"/>
+          </p:cNvPicPr>
+          <p:nvPr/>
+        </p:nvPicPr>
+        <p:blipFill>
+          <a:blip r:embed="rId4"/>
+          <a:srcRect t="30404" b="34912"/>
+          <a:stretch>
+            <a:fillRect/>
+          </a:stretch>
+        </p:blipFill>
+        <p:spPr>
+          <a:xfrm>
+            <a:off x="10225937" y="-18289"/>
+            <a:ext cx="1950925" cy="676657"/>
+          </a:xfrm>
+          <a:prstGeom prst="rect">
+            <a:avLst/>
+          </a:prstGeom>
+        </p:spPr>
+      </p:pic>
+      <p:sp>
+        <p:nvSpPr>
+          <p:cNvPr id="27" name="Shape 15">
+            <a:extLst>
+              <a:ext uri="{FF2B5EF4-FFF2-40B4-BE49-F238E27FC236}">
+                <a16:creationId xmlns:a16="http://schemas.microsoft.com/office/drawing/2014/main" id="{9DB40A8B-147A-09E3-694B-E4EFE3AAF11D}"/>
+              </a:ext>
+            </a:extLst>
+          </p:cNvPr>
+          <p:cNvSpPr/>
+          <p:nvPr/>
+        </p:nvSpPr>
+        <p:spPr>
+          <a:xfrm>
+            <a:off x="7744968" y="5093208"/>
+            <a:ext cx="3182112" cy="658368"/>
+          </a:xfrm>
+          <a:prstGeom prst="roundRect">
+            <a:avLst>
+              <a:gd name="adj" fmla="val 11111"/>
+            </a:avLst>
+          </a:prstGeom>
+          <a:solidFill>
+            <a:srgbClr val="FFFFFF"/>
+          </a:solidFill>
+          <a:ln w="12700">
+            <a:solidFill>
+              <a:srgbClr val="D9E3EA"/>
+            </a:solidFill>
+            <a:prstDash val="solid"/>
+          </a:ln>
+          <a:effectLst>
+            <a:outerShdw blurRad="12700" dist="50800" dir="2700000" algn="bl" rotWithShape="0">
+              <a:srgbClr val="AAB7C2">
+                <a:alpha val="12000"/>
+              </a:srgbClr>
+            </a:outerShdw>
+          </a:effectLst>
+        </p:spPr>
+        <p:txBody>
+          <a:bodyPr/>
+          <a:lstStyle/>
+          <a:p>
+            <a:endParaRPr lang="th-TH" dirty="0"/>
+          </a:p>
+        </p:txBody>
+      </p:sp>
+      <p:sp>
+        <p:nvSpPr>
+          <p:cNvPr id="29" name="Text 16">
+            <a:extLst>
+              <a:ext uri="{FF2B5EF4-FFF2-40B4-BE49-F238E27FC236}">
+                <a16:creationId xmlns:a16="http://schemas.microsoft.com/office/drawing/2014/main" id="{A7CA80B6-AFE9-CD2C-158F-739967FFF9E3}"/>
+              </a:ext>
+            </a:extLst>
+          </p:cNvPr>
+          <p:cNvSpPr/>
+          <p:nvPr/>
+        </p:nvSpPr>
+        <p:spPr>
+          <a:xfrm>
+            <a:off x="7909560" y="5239512"/>
+            <a:ext cx="384048" cy="320040"/>
+          </a:xfrm>
+          <a:prstGeom prst="rect">
+            <a:avLst/>
+          </a:prstGeom>
+          <a:noFill/>
+          <a:ln/>
+        </p:spPr>
+        <p:txBody>
+          <a:bodyPr wrap="square" lIns="0" tIns="0" rIns="0" bIns="0" rtlCol="0" anchor="ctr">
+            <a:normAutofit/>
+          </a:bodyPr>
+          <a:lstStyle/>
+          <a:p>
+            <a:pPr marL="0" indent="0">
+              <a:buNone/>
+            </a:pPr>
+            <a:r>
+              <a:rPr lang="en-US" sz="1300" b="1" dirty="0">
+                <a:solidFill>
+                  <a:srgbClr val="2A7F80"/>
+                </a:solidFill>
+                <a:latin typeface="Tahoma" pitchFamily="34" charset="0"/>
+                <a:ea typeface="Tahoma" pitchFamily="34" charset="-122"/>
+                <a:cs typeface="Tahoma" pitchFamily="34" charset="-120"/>
+              </a:rPr>
+              <a:t>04</a:t>
+            </a:r>
+            <a:endParaRPr lang="en-US" sz="1300" dirty="0"/>
+          </a:p>
+        </p:txBody>
+      </p:sp>
+      <p:sp>
+        <p:nvSpPr>
+          <p:cNvPr id="31" name="Text 17">
+            <a:extLst>
+              <a:ext uri="{FF2B5EF4-FFF2-40B4-BE49-F238E27FC236}">
+                <a16:creationId xmlns:a16="http://schemas.microsoft.com/office/drawing/2014/main" id="{29B93AD1-87BC-F386-6F27-CE96D08E0EAE}"/>
+              </a:ext>
+            </a:extLst>
+          </p:cNvPr>
+          <p:cNvSpPr/>
+          <p:nvPr/>
+        </p:nvSpPr>
+        <p:spPr>
+          <a:xfrm>
+            <a:off x="8339328" y="5193792"/>
+            <a:ext cx="2359152" cy="420624"/>
+          </a:xfrm>
+          <a:prstGeom prst="rect">
+            <a:avLst/>
+          </a:prstGeom>
+          <a:noFill/>
+          <a:ln/>
+        </p:spPr>
+        <p:txBody>
+          <a:bodyPr wrap="square" lIns="0" tIns="0" rIns="0" bIns="0" rtlCol="0" anchor="ctr">
+            <a:normAutofit lnSpcReduction="10000"/>
+          </a:bodyPr>
+          <a:lstStyle/>
+          <a:p>
+            <a:pPr marL="0" indent="0">
+              <a:buNone/>
+            </a:pPr>
+            <a:r>
+              <a:rPr lang="th-TH" sz="1500" b="1" dirty="0">
+                <a:solidFill>
+                  <a:srgbClr val="17324D"/>
+                </a:solidFill>
+                <a:latin typeface="Tahoma" pitchFamily="34" charset="0"/>
+                <a:ea typeface="Tahoma" pitchFamily="34" charset="-122"/>
+                <a:cs typeface="Tahoma" pitchFamily="34" charset="-120"/>
+              </a:rPr>
+              <a:t>สรุปมติ และกำหนดการ</a:t>
+            </a:r>
+            <a:r>
+              <a:rPr lang="en-US" sz="1500" b="1" dirty="0" err="1">
+                <a:solidFill>
+                  <a:srgbClr val="17324D"/>
+                </a:solidFill>
+                <a:latin typeface="Tahoma" pitchFamily="34" charset="0"/>
+                <a:ea typeface="Tahoma" pitchFamily="34" charset="-122"/>
+                <a:cs typeface="Tahoma" pitchFamily="34" charset="-120"/>
+              </a:rPr>
+              <a:t>ดำเนินงาน</a:t>
+            </a:r>
+            <a:r>
+              <a:rPr lang="th-TH" sz="1500" b="1" dirty="0">
+                <a:solidFill>
+                  <a:srgbClr val="17324D"/>
+                </a:solidFill>
+                <a:latin typeface="Tahoma" pitchFamily="34" charset="0"/>
+                <a:ea typeface="Tahoma" pitchFamily="34" charset="-122"/>
+                <a:cs typeface="Tahoma" pitchFamily="34" charset="-120"/>
+              </a:rPr>
+              <a:t>ถัดไป</a:t>
+            </a:r>
+            <a:endParaRPr lang="en-US" sz="1500" dirty="0"/>
+          </a:p>
+        </p:txBody>
+      </p:sp>
     </p:spTree>
   </p:cSld>
   <p:clrMapOvr>
@@ -1784,47 +1978,6 @@
       </p:sp>
       <p:sp>
         <p:nvSpPr>
-          <p:cNvPr id="4" name="Text 2"/>
-          <p:cNvSpPr/>
-          <p:nvPr/>
-        </p:nvSpPr>
-        <p:spPr>
-          <a:xfrm>
-            <a:off x="11183112" y="292608"/>
-            <a:ext cx="502920" cy="411480"/>
-          </a:xfrm>
-          <a:prstGeom prst="rect">
-            <a:avLst/>
-          </a:prstGeom>
-          <a:noFill/>
-          <a:ln/>
-        </p:spPr>
-        <p:txBody>
-          <a:bodyPr wrap="square" lIns="0" tIns="0" rIns="0" bIns="0" rtlCol="0" anchor="ctr">
-            <a:normAutofit/>
-          </a:bodyPr>
-          <a:lstStyle/>
-          <a:p>
-            <a:pPr marL="0" indent="0" algn="r">
-              <a:buNone/>
-            </a:pPr>
-            <a:r>
-              <a:rPr lang="en-US" sz="1300" dirty="0">
-                <a:solidFill>
-                  <a:srgbClr val="6B7F90"/>
-                </a:solidFill>
-                <a:latin typeface="Tahoma" pitchFamily="34" charset="0"/>
-                <a:ea typeface="Tahoma" pitchFamily="34" charset="-122"/>
-                <a:cs typeface="Tahoma" pitchFamily="34" charset="-120"/>
-              </a:rPr>
-              <a:t>02</a:t>
-            </a:r>
-            <a:endParaRPr lang="en-US" sz="1300" dirty="0"/>
-          </a:p>
-        </p:txBody>
-      </p:sp>
-      <p:sp>
-        <p:nvSpPr>
           <p:cNvPr id="5" name="Shape 3"/>
           <p:cNvSpPr/>
           <p:nvPr/>
@@ -2597,6 +2750,37 @@
           </a:p>
         </p:txBody>
       </p:sp>
+      <p:pic>
+        <p:nvPicPr>
+          <p:cNvPr id="26" name="รูปภาพ 25" descr="Intelligent Software Solutions&#10;&#10;เนื้อหาที่สร้างโดย AI อาจไม่ถูกต้อง">
+            <a:extLst>
+              <a:ext uri="{FF2B5EF4-FFF2-40B4-BE49-F238E27FC236}">
+                <a16:creationId xmlns:a16="http://schemas.microsoft.com/office/drawing/2014/main" id="{0101571B-6AE6-C235-C41F-D2654504ED6B}"/>
+              </a:ext>
+            </a:extLst>
+          </p:cNvPr>
+          <p:cNvPicPr>
+            <a:picLocks noChangeAspect="1"/>
+          </p:cNvPicPr>
+          <p:nvPr/>
+        </p:nvPicPr>
+        <p:blipFill>
+          <a:blip r:embed="rId3"/>
+          <a:srcRect t="30404" b="34912"/>
+          <a:stretch>
+            <a:fillRect/>
+          </a:stretch>
+        </p:blipFill>
+        <p:spPr>
+          <a:xfrm>
+            <a:off x="10225937" y="-18289"/>
+            <a:ext cx="1950925" cy="676657"/>
+          </a:xfrm>
+          <a:prstGeom prst="rect">
+            <a:avLst/>
+          </a:prstGeom>
+        </p:spPr>
+      </p:pic>
     </p:spTree>
   </p:cSld>
   <p:clrMapOvr>
@@ -2690,47 +2874,6 @@
       </p:sp>
       <p:sp>
         <p:nvSpPr>
-          <p:cNvPr id="4" name="Text 2"/>
-          <p:cNvSpPr/>
-          <p:nvPr/>
-        </p:nvSpPr>
-        <p:spPr>
-          <a:xfrm>
-            <a:off x="11183112" y="292608"/>
-            <a:ext cx="502920" cy="411480"/>
-          </a:xfrm>
-          <a:prstGeom prst="rect">
-            <a:avLst/>
-          </a:prstGeom>
-          <a:noFill/>
-          <a:ln/>
-        </p:spPr>
-        <p:txBody>
-          <a:bodyPr wrap="square" lIns="0" tIns="0" rIns="0" bIns="0" rtlCol="0" anchor="ctr">
-            <a:normAutofit/>
-          </a:bodyPr>
-          <a:lstStyle/>
-          <a:p>
-            <a:pPr marL="0" indent="0" algn="r">
-              <a:buNone/>
-            </a:pPr>
-            <a:r>
-              <a:rPr lang="en-US" sz="1300" dirty="0">
-                <a:solidFill>
-                  <a:srgbClr val="6B7F90"/>
-                </a:solidFill>
-                <a:latin typeface="Tahoma" pitchFamily="34" charset="0"/>
-                <a:ea typeface="Tahoma" pitchFamily="34" charset="-122"/>
-                <a:cs typeface="Tahoma" pitchFamily="34" charset="-120"/>
-              </a:rPr>
-              <a:t>03</a:t>
-            </a:r>
-            <a:endParaRPr lang="en-US" sz="1300" dirty="0"/>
-          </a:p>
-        </p:txBody>
-      </p:sp>
-      <p:sp>
-        <p:nvSpPr>
           <p:cNvPr id="5" name="Shape 3"/>
           <p:cNvSpPr/>
           <p:nvPr/>
@@ -4087,6 +4230,37 @@
           </a:p>
         </p:txBody>
       </p:sp>
+      <p:pic>
+        <p:nvPicPr>
+          <p:cNvPr id="46" name="รูปภาพ 45" descr="Intelligent Software Solutions&#10;&#10;เนื้อหาที่สร้างโดย AI อาจไม่ถูกต้อง">
+            <a:extLst>
+              <a:ext uri="{FF2B5EF4-FFF2-40B4-BE49-F238E27FC236}">
+                <a16:creationId xmlns:a16="http://schemas.microsoft.com/office/drawing/2014/main" id="{D6908E34-8835-B7D2-62D6-F0DD3C8F17CE}"/>
+              </a:ext>
+            </a:extLst>
+          </p:cNvPr>
+          <p:cNvPicPr>
+            <a:picLocks noChangeAspect="1"/>
+          </p:cNvPicPr>
+          <p:nvPr/>
+        </p:nvPicPr>
+        <p:blipFill>
+          <a:blip r:embed="rId3"/>
+          <a:srcRect t="30404" b="34912"/>
+          <a:stretch>
+            <a:fillRect/>
+          </a:stretch>
+        </p:blipFill>
+        <p:spPr>
+          <a:xfrm>
+            <a:off x="10225937" y="-18289"/>
+            <a:ext cx="1950925" cy="676657"/>
+          </a:xfrm>
+          <a:prstGeom prst="rect">
+            <a:avLst/>
+          </a:prstGeom>
+        </p:spPr>
+      </p:pic>
     </p:spTree>
     <p:extLst>
       <p:ext uri="{BB962C8B-B14F-4D97-AF65-F5344CB8AC3E}">
@@ -4193,47 +4367,6 @@
       </p:sp>
       <p:sp>
         <p:nvSpPr>
-          <p:cNvPr id="4" name="Text 2"/>
-          <p:cNvSpPr/>
-          <p:nvPr/>
-        </p:nvSpPr>
-        <p:spPr>
-          <a:xfrm>
-            <a:off x="11183112" y="292608"/>
-            <a:ext cx="502920" cy="411480"/>
-          </a:xfrm>
-          <a:prstGeom prst="rect">
-            <a:avLst/>
-          </a:prstGeom>
-          <a:noFill/>
-          <a:ln/>
-        </p:spPr>
-        <p:txBody>
-          <a:bodyPr wrap="square" lIns="0" tIns="0" rIns="0" bIns="0" rtlCol="0" anchor="ctr">
-            <a:normAutofit/>
-          </a:bodyPr>
-          <a:lstStyle/>
-          <a:p>
-            <a:pPr marL="0" indent="0" algn="r">
-              <a:buNone/>
-            </a:pPr>
-            <a:r>
-              <a:rPr lang="en-US" sz="1300" dirty="0">
-                <a:solidFill>
-                  <a:srgbClr val="6B7F90"/>
-                </a:solidFill>
-                <a:latin typeface="Tahoma" pitchFamily="34" charset="0"/>
-                <a:ea typeface="Tahoma" pitchFamily="34" charset="-122"/>
-                <a:cs typeface="Tahoma" pitchFamily="34" charset="-120"/>
-              </a:rPr>
-              <a:t>04</a:t>
-            </a:r>
-            <a:endParaRPr lang="en-US" sz="1300" dirty="0"/>
-          </a:p>
-        </p:txBody>
-      </p:sp>
-      <p:sp>
-        <p:nvSpPr>
           <p:cNvPr id="5" name="Shape 3"/>
           <p:cNvSpPr/>
           <p:nvPr/>
@@ -5223,6 +5356,37 @@
           </a:p>
         </p:txBody>
       </p:sp>
+      <p:pic>
+        <p:nvPicPr>
+          <p:cNvPr id="33" name="รูปภาพ 32" descr="Intelligent Software Solutions&#10;&#10;เนื้อหาที่สร้างโดย AI อาจไม่ถูกต้อง">
+            <a:extLst>
+              <a:ext uri="{FF2B5EF4-FFF2-40B4-BE49-F238E27FC236}">
+                <a16:creationId xmlns:a16="http://schemas.microsoft.com/office/drawing/2014/main" id="{5A936A08-3D02-20EF-6D62-3ECC256CFFC1}"/>
+              </a:ext>
+            </a:extLst>
+          </p:cNvPr>
+          <p:cNvPicPr>
+            <a:picLocks noChangeAspect="1"/>
+          </p:cNvPicPr>
+          <p:nvPr/>
+        </p:nvPicPr>
+        <p:blipFill>
+          <a:blip r:embed="rId3"/>
+          <a:srcRect t="30404" b="34912"/>
+          <a:stretch>
+            <a:fillRect/>
+          </a:stretch>
+        </p:blipFill>
+        <p:spPr>
+          <a:xfrm>
+            <a:off x="10225937" y="-18289"/>
+            <a:ext cx="1950925" cy="676657"/>
+          </a:xfrm>
+          <a:prstGeom prst="rect">
+            <a:avLst/>
+          </a:prstGeom>
+        </p:spPr>
+      </p:pic>
     </p:spTree>
   </p:cSld>
   <p:clrMapOvr>
@@ -5324,47 +5488,6 @@
       </p:sp>
       <p:sp>
         <p:nvSpPr>
-          <p:cNvPr id="4" name="Text 2"/>
-          <p:cNvSpPr/>
-          <p:nvPr/>
-        </p:nvSpPr>
-        <p:spPr>
-          <a:xfrm>
-            <a:off x="11183112" y="292608"/>
-            <a:ext cx="502920" cy="411480"/>
-          </a:xfrm>
-          <a:prstGeom prst="rect">
-            <a:avLst/>
-          </a:prstGeom>
-          <a:noFill/>
-          <a:ln/>
-        </p:spPr>
-        <p:txBody>
-          <a:bodyPr wrap="square" lIns="0" tIns="0" rIns="0" bIns="0" rtlCol="0" anchor="ctr">
-            <a:normAutofit/>
-          </a:bodyPr>
-          <a:lstStyle/>
-          <a:p>
-            <a:pPr marL="0" indent="0" algn="r">
-              <a:buNone/>
-            </a:pPr>
-            <a:r>
-              <a:rPr lang="en-US" sz="1300" dirty="0">
-                <a:solidFill>
-                  <a:srgbClr val="6B7F90"/>
-                </a:solidFill>
-                <a:latin typeface="Tahoma" pitchFamily="34" charset="0"/>
-                <a:ea typeface="Tahoma" pitchFamily="34" charset="-122"/>
-                <a:cs typeface="Tahoma" pitchFamily="34" charset="-120"/>
-              </a:rPr>
-              <a:t>05</a:t>
-            </a:r>
-            <a:endParaRPr lang="en-US" sz="1300" dirty="0"/>
-          </a:p>
-        </p:txBody>
-      </p:sp>
-      <p:sp>
-        <p:nvSpPr>
           <p:cNvPr id="5" name="Shape 3"/>
           <p:cNvSpPr/>
           <p:nvPr/>
@@ -6097,8 +6220,8 @@
         </p:nvSpPr>
         <p:spPr>
           <a:xfrm>
-            <a:off x="508000" y="4572000"/>
-            <a:ext cx="11176000" cy="990600"/>
+            <a:off x="4063331" y="4194048"/>
+            <a:ext cx="4888163" cy="990600"/>
           </a:xfrm>
           <a:prstGeom prst="roundRect">
             <a:avLst/>
@@ -6151,7 +6274,7 @@
         </p:nvSpPr>
         <p:spPr>
           <a:xfrm>
-            <a:off x="787400" y="4889500"/>
+            <a:off x="4342731" y="4511548"/>
             <a:ext cx="1651000" cy="330200"/>
           </a:xfrm>
           <a:prstGeom prst="rect">
@@ -6191,8 +6314,8 @@
         </p:nvSpPr>
         <p:spPr>
           <a:xfrm>
-            <a:off x="2476500" y="4699000"/>
-            <a:ext cx="8890000" cy="685800"/>
+            <a:off x="5923546" y="4263136"/>
+            <a:ext cx="2642938" cy="904240"/>
           </a:xfrm>
           <a:prstGeom prst="rect">
             <a:avLst/>
@@ -6205,47 +6328,114 @@
           </a:bodyPr>
           <a:lstStyle/>
           <a:p>
-            <a:r>
-              <a:rPr lang="en-US" sz="1500">
+            <a:pPr marL="342900" indent="-342900">
+              <a:buAutoNum type="arabicPeriod"/>
+            </a:pPr>
+            <a:r>
+              <a:rPr lang="en-US" sz="1400" dirty="0">
                 <a:solidFill>
                   <a:srgbClr val="486174"/>
                 </a:solidFill>
-                <a:latin typeface="Tahoma" panose="020B0604030504040204" pitchFamily="34" charset="0"/>
               </a:rPr>
               <a:t>Source Code </a:t>
             </a:r>
             <a:r>
-              <a:rPr lang="th-TH" sz="1500">
+              <a:rPr lang="th-TH" sz="1400" dirty="0">
                 <a:solidFill>
                   <a:srgbClr val="486174"/>
                 </a:solidFill>
-                <a:latin typeface="Tahoma" panose="020B0604030504040204" pitchFamily="34" charset="0"/>
-              </a:rPr>
-              <a:t>และฐานข้อมูล • คู่มือผู้ใช้งาน • ผลการทดสอบ </a:t>
-            </a:r>
-            <a:r>
-              <a:rPr lang="en-US" sz="1500">
+              </a:rPr>
+              <a:t>และฐานข้อมูล</a:t>
+            </a:r>
+          </a:p>
+          <a:p>
+            <a:pPr marL="342900" indent="-342900">
+              <a:buAutoNum type="arabicPeriod"/>
+            </a:pPr>
+            <a:r>
+              <a:rPr lang="th-TH" sz="1400" dirty="0">
                 <a:solidFill>
                   <a:srgbClr val="486174"/>
                 </a:solidFill>
-                <a:latin typeface="Tahoma" panose="020B0604030504040204" pitchFamily="34" charset="0"/>
+              </a:rPr>
+              <a:t>คู่มือผู้ใช้งาน</a:t>
+            </a:r>
+          </a:p>
+          <a:p>
+            <a:pPr marL="342900" indent="-342900">
+              <a:buAutoNum type="arabicPeriod"/>
+            </a:pPr>
+            <a:r>
+              <a:rPr lang="th-TH" sz="1400" dirty="0">
+                <a:solidFill>
+                  <a:srgbClr val="486174"/>
+                </a:solidFill>
+              </a:rPr>
+              <a:t>ผลการทดสอบ </a:t>
+            </a:r>
+            <a:r>
+              <a:rPr lang="en-US" sz="1400" dirty="0">
+                <a:solidFill>
+                  <a:srgbClr val="486174"/>
+                </a:solidFill>
               </a:rPr>
               <a:t>UAT</a:t>
             </a:r>
-          </a:p>
-          <a:p>
-            <a:r>
-              <a:rPr lang="th-TH" sz="1500">
+            <a:r>
+              <a:rPr lang="th-TH" sz="1400" dirty="0">
                 <a:solidFill>
                   <a:srgbClr val="486174"/>
                 </a:solidFill>
-                <a:latin typeface="Tahoma" panose="020B0604030504040204" pitchFamily="34" charset="0"/>
+              </a:rPr>
+              <a:t>  </a:t>
+            </a:r>
+          </a:p>
+          <a:p>
+            <a:pPr marL="342900" indent="-342900">
+              <a:buAutoNum type="arabicPeriod"/>
+            </a:pPr>
+            <a:r>
+              <a:rPr lang="th-TH" sz="1400" dirty="0">
+                <a:solidFill>
+                  <a:srgbClr val="486174"/>
+                </a:solidFill>
               </a:rPr>
               <a:t>การติดตั้ง อบรม และดูแลหลังขึ้นระบบ</a:t>
             </a:r>
           </a:p>
         </p:txBody>
       </p:sp>
+      <p:pic>
+        <p:nvPicPr>
+          <p:cNvPr id="29" name="รูปภาพ 28" descr="Intelligent Software Solutions&#10;&#10;เนื้อหาที่สร้างโดย AI อาจไม่ถูกต้อง">
+            <a:extLst>
+              <a:ext uri="{FF2B5EF4-FFF2-40B4-BE49-F238E27FC236}">
+                <a16:creationId xmlns:a16="http://schemas.microsoft.com/office/drawing/2014/main" id="{908D771F-9F0A-C7EA-13BB-2734E55A6A8C}"/>
+              </a:ext>
+            </a:extLst>
+          </p:cNvPr>
+          <p:cNvPicPr>
+            <a:picLocks noChangeAspect="1"/>
+          </p:cNvPicPr>
+          <p:nvPr/>
+        </p:nvPicPr>
+        <p:blipFill>
+          <a:blip r:embed="rId3"/>
+          <a:srcRect t="30404" b="34912"/>
+          <a:stretch>
+            <a:fillRect/>
+          </a:stretch>
+        </p:blipFill>
+        <p:spPr>
+          <a:xfrm>
+            <a:off x="10225937" y="-18289"/>
+            <a:ext cx="1950925" cy="676657"/>
+          </a:xfrm>
+          <a:prstGeom prst="rect">
+            <a:avLst/>
+          </a:prstGeom>
+        </p:spPr>
+      </p:pic>
     </p:spTree>
   </p:cSld>
   <p:clrMapOvr>

</xml_diff>